<commit_message>
test(freep): add surface chart geometry planner evidence
</commit_message>
<xml_diff>
--- a/tools/FreeP.RenderCompare/corpus/22-chart-baseline-depth.pptx
+++ b/tools/FreeP.RenderCompare/corpus/22-chart-baseline-depth.pptx
@@ -341,7 +341,7 @@
               <c:strCache>
                 <c:ptCount val="1"/>
                 <c:pt idx="0">
-                  <c:v>High band</c:v>
+                  <c:v>Mid band</c:v>
                 </c:pt>
               </c:strCache>
             </c:strRef>
@@ -366,6 +366,56 @@
           <c:val>
             <c:numRef>
               <c:f>ChartData!$C$2:$C$4</c:f>
+              <c:numCache>
+                <c:formatCode>General</c:formatCode>
+                <c:ptCount val="3"/>
+                <c:pt idx="0">
+                  <c:v>18</c:v>
+                </c:pt>
+                <c:pt idx="1">
+                  <c:v>22</c:v>
+                </c:pt>
+                <c:pt idx="2">
+                  <c:v>26</c:v>
+                </c:pt>
+              </c:numCache>
+            </c:numRef>
+          </c:val>
+        </c:ser>
+        <c:ser>
+          <c:idx val="2"/>
+          <c:order val="2"/>
+          <c:tx>
+            <c:strRef>
+              <c:f>ChartData!$D$1</c:f>
+              <c:strCache>
+                <c:ptCount val="1"/>
+                <c:pt idx="0">
+                  <c:v>High band</c:v>
+                </c:pt>
+              </c:strCache>
+            </c:strRef>
+          </c:tx>
+          <c:cat>
+            <c:strRef>
+              <c:f>ChartData!$A$2:$A$4</c:f>
+              <c:strCache>
+                <c:ptCount val="3"/>
+                <c:pt idx="0">
+                  <c:v>North</c:v>
+                </c:pt>
+                <c:pt idx="1">
+                  <c:v>East</c:v>
+                </c:pt>
+                <c:pt idx="2">
+                  <c:v>South</c:v>
+                </c:pt>
+              </c:strCache>
+            </c:strRef>
+          </c:cat>
+          <c:val>
+            <c:numRef>
+              <c:f>ChartData!$D$2:$D$4</c:f>
               <c:numCache>
                 <c:formatCode>General</c:formatCode>
                 <c:ptCount val="3"/>

</xml_diff>